<commit_message>
Submission 2 (Capstone 2 Project Statement)
Revamped the objective and aligned it closer to SMART framework
</commit_message>
<xml_diff>
--- a/Capstone2/Capstone 2 - Problem_Statement_Worksheet.pptx
+++ b/Capstone2/Capstone 2 - Problem_Statement_Worksheet.pptx
@@ -3418,8 +3418,8 @@
         </p:nvSpPr>
         <p:spPr>
           <a:xfrm>
-            <a:off x="137949" y="1019970"/>
-            <a:ext cx="4344156" cy="4923630"/>
+            <a:off x="137949" y="1019969"/>
+            <a:ext cx="4344156" cy="5389795"/>
           </a:xfrm>
           <a:prstGeom prst="rect">
             <a:avLst/>
@@ -3481,7 +3481,7 @@
         <p:spPr>
           <a:xfrm>
             <a:off x="4587388" y="1019974"/>
-            <a:ext cx="4344156" cy="4923626"/>
+            <a:ext cx="4344156" cy="5389790"/>
           </a:xfrm>
           <a:prstGeom prst="rect">
             <a:avLst/>
@@ -3610,7 +3610,7 @@
         </p:nvSpPr>
         <p:spPr>
           <a:xfrm>
-            <a:off x="4668375" y="1333449"/>
+            <a:off x="4668375" y="1055541"/>
             <a:ext cx="288315" cy="288315"/>
           </a:xfrm>
           <a:prstGeom prst="rect">
@@ -3744,7 +3744,7 @@
         </p:nvSpPr>
         <p:spPr>
           <a:xfrm>
-            <a:off x="5050634" y="1365503"/>
+            <a:off x="5050634" y="1087595"/>
             <a:ext cx="3597454" cy="224203"/>
           </a:xfrm>
           <a:prstGeom prst="rect">
@@ -3810,7 +3810,7 @@
         </p:nvSpPr>
         <p:spPr>
           <a:xfrm>
-            <a:off x="4668375" y="2922418"/>
+            <a:off x="4668375" y="2832768"/>
             <a:ext cx="288315" cy="288315"/>
           </a:xfrm>
           <a:prstGeom prst="rect">
@@ -3878,7 +3878,7 @@
         </p:nvSpPr>
         <p:spPr>
           <a:xfrm>
-            <a:off x="218936" y="2764389"/>
+            <a:off x="218936" y="2629730"/>
             <a:ext cx="288315" cy="288315"/>
           </a:xfrm>
           <a:prstGeom prst="rect">
@@ -3915,7 +3915,7 @@
               <a:buNone/>
             </a:pPr>
             <a:r>
-              <a:rPr lang="en-AU" sz="1428" b="0" i="0" u="none" strike="noStrike" cap="none">
+              <a:rPr lang="en-AU" sz="1428" b="0" i="0" u="none" strike="noStrike" cap="none" dirty="0">
                 <a:solidFill>
                   <a:schemeClr val="lt1"/>
                 </a:solidFill>
@@ -3926,7 +3926,7 @@
               </a:rPr>
               <a:t>2</a:t>
             </a:r>
-            <a:endParaRPr sz="1400" b="0" i="0" u="none" strike="noStrike" cap="none">
+            <a:endParaRPr sz="1400" b="0" i="0" u="none" strike="noStrike" cap="none" dirty="0">
               <a:solidFill>
                 <a:srgbClr val="000000"/>
               </a:solidFill>
@@ -3946,7 +3946,7 @@
         </p:nvSpPr>
         <p:spPr>
           <a:xfrm>
-            <a:off x="601195" y="2796445"/>
+            <a:off x="601195" y="2671514"/>
             <a:ext cx="3597454" cy="224203"/>
           </a:xfrm>
           <a:prstGeom prst="rect">
@@ -4012,7 +4012,7 @@
         </p:nvSpPr>
         <p:spPr>
           <a:xfrm>
-            <a:off x="5050634" y="2954474"/>
+            <a:off x="5050634" y="2864824"/>
             <a:ext cx="3597454" cy="224203"/>
           </a:xfrm>
           <a:prstGeom prst="rect">
@@ -4078,7 +4078,7 @@
         </p:nvSpPr>
         <p:spPr>
           <a:xfrm>
-            <a:off x="218936" y="4750405"/>
+            <a:off x="218936" y="4912916"/>
             <a:ext cx="288315" cy="288315"/>
           </a:xfrm>
           <a:prstGeom prst="rect">
@@ -4146,7 +4146,7 @@
         </p:nvSpPr>
         <p:spPr>
           <a:xfrm>
-            <a:off x="4668375" y="4513007"/>
+            <a:off x="4668375" y="5006066"/>
             <a:ext cx="288315" cy="288315"/>
           </a:xfrm>
           <a:prstGeom prst="rect">
@@ -4214,7 +4214,7 @@
         </p:nvSpPr>
         <p:spPr>
           <a:xfrm>
-            <a:off x="601195" y="4784692"/>
+            <a:off x="601195" y="4947203"/>
             <a:ext cx="3597454" cy="219740"/>
           </a:xfrm>
           <a:prstGeom prst="rect">
@@ -4280,7 +4280,7 @@
         </p:nvSpPr>
         <p:spPr>
           <a:xfrm>
-            <a:off x="5050634" y="4545063"/>
+            <a:off x="5050634" y="5038122"/>
             <a:ext cx="3597454" cy="224203"/>
           </a:xfrm>
           <a:prstGeom prst="rect">
@@ -4354,8 +4354,8 @@
         </p:nvSpPr>
         <p:spPr>
           <a:xfrm>
-            <a:off x="143108" y="1387004"/>
-            <a:ext cx="4324418" cy="1410642"/>
+            <a:off x="143108" y="1324822"/>
+            <a:ext cx="4324418" cy="1304990"/>
           </a:xfrm>
           <a:prstGeom prst="rect">
             <a:avLst/>
@@ -4384,8 +4384,8 @@
               <a:buNone/>
             </a:pPr>
             <a:r>
-              <a:rPr lang="en-US" sz="1200" dirty="0"/>
-              <a:t>YouTube uses a combination of factors such as the number of views, shares, comments and likes to determine whether a video is ‘Trending’. There could be other slightly indiscernible features identified in the data which could bolster its success rate, which is worth identifying.</a:t>
+              <a:rPr lang="en-US" sz="1100" dirty="0"/>
+              <a:t>YouTube updates its trending list every 15min using a combination of factors such as the number of views, temperature, age of video, etc. Although its not clear what factors keep a video popping up in the trending list repeatedly. Identifying such features in the data could bolster the success of a video (i.e. make it frequently trend).</a:t>
             </a:r>
           </a:p>
         </p:txBody>
@@ -4398,8 +4398,8 @@
         </p:nvSpPr>
         <p:spPr>
           <a:xfrm>
-            <a:off x="143108" y="3035178"/>
-            <a:ext cx="4324418" cy="1349010"/>
+            <a:off x="143108" y="2910246"/>
+            <a:ext cx="4324418" cy="1660567"/>
           </a:xfrm>
           <a:prstGeom prst="rect">
             <a:avLst/>
@@ -4428,7 +4428,7 @@
               <a:buNone/>
             </a:pPr>
             <a:r>
-              <a:rPr lang="en-US" sz="1200" i="0" u="none" strike="noStrike" cap="none" dirty="0">
+              <a:rPr lang="en-US" sz="1100" i="0" u="none" strike="noStrike" cap="none" dirty="0">
                 <a:solidFill>
                   <a:srgbClr val="000000"/>
                 </a:solidFill>
@@ -4437,7 +4437,7 @@
                 <a:cs typeface="Arial"/>
                 <a:sym typeface="Arial"/>
               </a:rPr>
-              <a:t>Objective would be to predict the success criteria of a video based on 1/more of the following parameters:</a:t>
+              <a:t>Objective would be to model a classifier that predicts whether a trending video could pop up in YouTube’s trending list twice or higher. This could be estimated based on 1/more of the following parameters:</a:t>
             </a:r>
           </a:p>
           <a:p>
@@ -4455,7 +4455,7 @@
               <a:buChar char="•"/>
             </a:pPr>
             <a:r>
-              <a:rPr lang="en-US" sz="1200" i="0" u="none" strike="noStrike" cap="none" dirty="0">
+              <a:rPr lang="en-US" sz="1100" i="0" u="none" strike="noStrike" cap="none" dirty="0">
                 <a:solidFill>
                   <a:srgbClr val="000000"/>
                 </a:solidFill>
@@ -4464,7 +4464,7 @@
                 <a:cs typeface="Arial"/>
                 <a:sym typeface="Arial"/>
               </a:rPr>
-              <a:t>The direct parameters (such as, likes, dislikes, views, number of comments, and number of shares)</a:t>
+              <a:t>Viewer count</a:t>
             </a:r>
           </a:p>
           <a:p>
@@ -4482,7 +4482,7 @@
               <a:buChar char="•"/>
             </a:pPr>
             <a:r>
-              <a:rPr lang="en-US" sz="1200" i="0" u="none" strike="noStrike" cap="none" dirty="0">
+              <a:rPr lang="en-IN" sz="1100" i="0" u="none" strike="noStrike" cap="none" dirty="0">
                 <a:solidFill>
                   <a:srgbClr val="000000"/>
                 </a:solidFill>
@@ -4491,9 +4491,72 @@
                 <a:cs typeface="Arial"/>
                 <a:sym typeface="Arial"/>
               </a:rPr>
-              <a:t>Indirect factors include number of tags, Title length, time of upload, etc. </a:t>
+              <a:t>Interactive parameters: Like, Dislikes, and Comment count</a:t>
             </a:r>
-            <a:endParaRPr sz="1200" i="0" u="none" strike="noStrike" cap="none" dirty="0">
+          </a:p>
+          <a:p>
+            <a:pPr marL="285750" marR="0" lvl="0" indent="-285750" algn="l" rtl="0">
+              <a:lnSpc>
+                <a:spcPct val="100000"/>
+              </a:lnSpc>
+              <a:spcBef>
+                <a:spcPts val="0"/>
+              </a:spcBef>
+              <a:spcAft>
+                <a:spcPts val="0"/>
+              </a:spcAft>
+              <a:buFont typeface="Arial" panose="020B0604020202020204" pitchFamily="34" charset="0"/>
+              <a:buChar char="•"/>
+            </a:pPr>
+            <a:r>
+              <a:rPr lang="en-IN" sz="1100" dirty="0"/>
+              <a:t>Age of a video</a:t>
+            </a:r>
+          </a:p>
+          <a:p>
+            <a:pPr marL="285750" marR="0" lvl="0" indent="-285750" algn="l" rtl="0">
+              <a:lnSpc>
+                <a:spcPct val="100000"/>
+              </a:lnSpc>
+              <a:spcBef>
+                <a:spcPts val="0"/>
+              </a:spcBef>
+              <a:spcAft>
+                <a:spcPts val="0"/>
+              </a:spcAft>
+              <a:buFont typeface="Arial" panose="020B0604020202020204" pitchFamily="34" charset="0"/>
+              <a:buChar char="•"/>
+            </a:pPr>
+            <a:r>
+              <a:rPr lang="en-IN" sz="1100" dirty="0"/>
+              <a:t>Temperature (how quickly the video generates views)</a:t>
+            </a:r>
+          </a:p>
+          <a:p>
+            <a:pPr marR="0" lvl="0" algn="l" rtl="0">
+              <a:lnSpc>
+                <a:spcPct val="100000"/>
+              </a:lnSpc>
+              <a:spcBef>
+                <a:spcPts val="600"/>
+              </a:spcBef>
+              <a:spcAft>
+                <a:spcPts val="0"/>
+              </a:spcAft>
+            </a:pPr>
+            <a:r>
+              <a:rPr lang="en-IN" sz="1100" i="0" u="none" strike="noStrike" cap="none" dirty="0">
+                <a:solidFill>
+                  <a:srgbClr val="000000"/>
+                </a:solidFill>
+                <a:latin typeface="Arial"/>
+                <a:ea typeface="Arial"/>
+                <a:cs typeface="Arial"/>
+                <a:sym typeface="Arial"/>
+              </a:rPr>
+              <a:t>Aim is to complete capstone in 2 weeks from start of analysis.</a:t>
+            </a:r>
+            <a:endParaRPr sz="1100" i="0" u="none" strike="noStrike" cap="none" dirty="0">
               <a:solidFill>
                 <a:srgbClr val="000000"/>
               </a:solidFill>
@@ -4513,7 +4576,7 @@
         </p:nvSpPr>
         <p:spPr>
           <a:xfrm>
-            <a:off x="186842" y="5137525"/>
+            <a:off x="186842" y="5163844"/>
             <a:ext cx="4324418" cy="986972"/>
           </a:xfrm>
           <a:prstGeom prst="rect">
@@ -4543,7 +4606,7 @@
               <a:buNone/>
             </a:pPr>
             <a:r>
-              <a:rPr lang="en-US" sz="1200" b="0" i="0" u="none" strike="noStrike" cap="none" dirty="0">
+              <a:rPr lang="en-US" sz="1100" b="0" i="0" u="none" strike="noStrike" cap="none" dirty="0">
                 <a:solidFill>
                   <a:srgbClr val="000000"/>
                 </a:solidFill>
@@ -4552,21 +4615,24 @@
                 <a:cs typeface="Arial"/>
                 <a:sym typeface="Arial"/>
               </a:rPr>
-              <a:t>This analysis will primarily be restricted to the parameters which is in the control of a YouTuber. The Data from only a single region or set </a:t>
+              <a:t>This analysis will primarily be restricted to the measurable parameters which is in the control of a YouTuber. Since trending is selected based on appeal, relevance and content that </a:t>
             </a:r>
             <a:r>
-              <a:rPr lang="en-US" sz="1200" dirty="0"/>
-              <a:t>of select regions will be selected </a:t>
+              <a:rPr lang="en-US" sz="1100" dirty="0"/>
+              <a:t>c</a:t>
             </a:r>
-            <a:endParaRPr sz="1200" b="0" i="0" u="none" strike="noStrike" cap="none" dirty="0">
-              <a:solidFill>
-                <a:srgbClr val="000000"/>
-              </a:solidFill>
-              <a:latin typeface="Arial"/>
-              <a:ea typeface="Arial"/>
-              <a:cs typeface="Arial"/>
-              <a:sym typeface="Arial"/>
-            </a:endParaRPr>
+            <a:r>
+              <a:rPr lang="en-US" sz="1100" b="0" i="0" u="none" strike="noStrike" cap="none" dirty="0">
+                <a:solidFill>
+                  <a:srgbClr val="000000"/>
+                </a:solidFill>
+                <a:latin typeface="Arial"/>
+                <a:ea typeface="Arial"/>
+                <a:cs typeface="Arial"/>
+                <a:sym typeface="Arial"/>
+              </a:rPr>
+              <a:t>apture the breadth of what’s happening across the world, multi-country data is used for analysis (and not country specific).</a:t>
+            </a:r>
           </a:p>
         </p:txBody>
       </p:sp>
@@ -4578,7 +4644,7 @@
         </p:nvSpPr>
         <p:spPr>
           <a:xfrm>
-            <a:off x="4558232" y="1679241"/>
+            <a:off x="4558232" y="1401333"/>
             <a:ext cx="4324418" cy="1081065"/>
           </a:xfrm>
           <a:prstGeom prst="rect">
@@ -4608,7 +4674,7 @@
               <a:buNone/>
             </a:pPr>
             <a:r>
-              <a:rPr lang="en-US" sz="1070" b="1" i="0" u="none" strike="noStrike" cap="none" dirty="0">
+              <a:rPr lang="en-US" sz="1070" i="0" u="none" strike="noStrike" cap="none" dirty="0">
                 <a:solidFill>
                   <a:srgbClr val="000000"/>
                 </a:solidFill>
@@ -4617,9 +4683,9 @@
                 <a:cs typeface="Arial"/>
                 <a:sym typeface="Arial"/>
               </a:rPr>
-              <a:t>Data is available for many regions, thus video title is not necessarily restricted to a single language. </a:t>
+              <a:t>Data is available for many regions; thus, video title is not necessarily restricted to a single language. </a:t>
             </a:r>
-            <a:endParaRPr sz="1070" b="1" i="0" u="none" strike="noStrike" cap="none" dirty="0">
+            <a:endParaRPr sz="1070" i="0" u="none" strike="noStrike" cap="none" dirty="0">
               <a:solidFill>
                 <a:srgbClr val="000000"/>
               </a:solidFill>
@@ -4639,7 +4705,7 @@
         </p:nvSpPr>
         <p:spPr>
           <a:xfrm>
-            <a:off x="4590928" y="4800496"/>
+            <a:off x="4590928" y="5293555"/>
             <a:ext cx="4324418" cy="1081065"/>
           </a:xfrm>
           <a:prstGeom prst="rect">
@@ -4925,7 +4991,7 @@
         </p:nvSpPr>
         <p:spPr>
           <a:xfrm>
-            <a:off x="4607126" y="3262922"/>
+            <a:off x="4607126" y="3173272"/>
             <a:ext cx="4324418" cy="1081065"/>
           </a:xfrm>
           <a:prstGeom prst="rect">
@@ -4964,9 +5030,45 @@
                 <a:cs typeface="Arial"/>
                 <a:sym typeface="Arial"/>
               </a:rPr>
-              <a:t>&lt; Not Applicable &gt;</a:t>
+              <a:t>YouTube Content creators </a:t>
             </a:r>
-            <a:endParaRPr sz="1400" b="0" i="1" u="none" strike="noStrike" cap="none" dirty="0">
+            <a:r>
+              <a:rPr lang="en-AU" sz="1071" b="0" u="none" strike="noStrike" cap="none" dirty="0">
+                <a:solidFill>
+                  <a:srgbClr val="000000"/>
+                </a:solidFill>
+                <a:latin typeface="Arial"/>
+                <a:ea typeface="Arial"/>
+                <a:cs typeface="Arial"/>
+                <a:sym typeface="Arial"/>
+              </a:rPr>
+              <a:t>&amp; </a:t>
+            </a:r>
+            <a:r>
+              <a:rPr lang="en-AU" sz="1071" b="0" i="1" u="none" strike="noStrike" cap="none" dirty="0">
+                <a:solidFill>
+                  <a:srgbClr val="000000"/>
+                </a:solidFill>
+                <a:latin typeface="Arial"/>
+                <a:ea typeface="Arial"/>
+                <a:cs typeface="Arial"/>
+                <a:sym typeface="Arial"/>
+              </a:rPr>
+              <a:t>Marketing experts </a:t>
+            </a:r>
+            <a:r>
+              <a:rPr lang="en-AU" sz="1071" b="0" u="none" strike="noStrike" cap="none" dirty="0">
+                <a:solidFill>
+                  <a:srgbClr val="000000"/>
+                </a:solidFill>
+                <a:latin typeface="Arial"/>
+                <a:ea typeface="Arial"/>
+                <a:cs typeface="Arial"/>
+                <a:sym typeface="Arial"/>
+              </a:rPr>
+              <a:t>can benefit the most from this analysis.</a:t>
+            </a:r>
+            <a:endParaRPr sz="1400" b="0" u="none" strike="noStrike" cap="none" dirty="0">
               <a:solidFill>
                 <a:srgbClr val="000000"/>
               </a:solidFill>
@@ -5021,16 +5123,8 @@
               <a:buNone/>
             </a:pPr>
             <a:r>
-              <a:rPr lang="en-US" sz="1400" b="1" i="0" u="none" strike="noStrike" cap="none" dirty="0">
-                <a:solidFill>
-                  <a:srgbClr val="000000"/>
-                </a:solidFill>
-                <a:latin typeface="Arial"/>
-                <a:ea typeface="Arial"/>
-                <a:cs typeface="Arial"/>
-                <a:sym typeface="Arial"/>
-              </a:rPr>
-              <a:t>Estimating the “success” of a video based on trends identified in the data and additional features</a:t>
+              <a:rPr lang="en-US" dirty="0"/>
+              <a:t>Predicting Videos That Stay Trending: A Closer Look At YouTube’s Frequently Trending Content</a:t>
             </a:r>
             <a:endParaRPr sz="1400" b="1" i="0" u="none" strike="noStrike" cap="none" dirty="0">
               <a:solidFill>

</xml_diff>

<commit_message>
Update Capstone 2 - Problem_Statement_Worksheet.pptx
Intro updated
</commit_message>
<xml_diff>
--- a/Capstone2/Capstone 2 - Problem_Statement_Worksheet.pptx
+++ b/Capstone2/Capstone 2 - Problem_Statement_Worksheet.pptx
@@ -257,7 +257,7 @@
       </p15:sldGuideLst>
     </p:ext>
     <p:ext uri="http://customooxmlschemas.google.com/">
-      <go:slidesCustomData xmlns:go="http://customooxmlschemas.google.com/" xmlns:p15="http://schemas.microsoft.com/office/powerpoint/2012/main" xmlns:p14="http://schemas.microsoft.com/office/powerpoint/2010/main" xmlns:com="http://schemas.openxmlformats.org/drawingml/2006/compatibility" xmlns:pvml="urn:schemas-microsoft-com:office:powerpoint" xmlns:v="urn:schemas-microsoft-com:vml" xmlns:o="urn:schemas-microsoft-com:office:office" xmlns:dgm="http://schemas.openxmlformats.org/drawingml/2006/diagram" xmlns:c="http://schemas.openxmlformats.org/drawingml/2006/chart" xmlns:mv="urn:schemas-microsoft-com:mac:vml" xmlns:mc="http://schemas.openxmlformats.org/markup-compatibility/2006" xmlns="" r:id="rId7" roundtripDataSignature="AMtx7mjdo7FECp685JsX7/4pIVeoAktjNA=="/>
+      <go:slidesCustomData xmlns="" xmlns:mc="http://schemas.openxmlformats.org/markup-compatibility/2006" xmlns:mv="urn:schemas-microsoft-com:mac:vml" xmlns:c="http://schemas.openxmlformats.org/drawingml/2006/chart" xmlns:dgm="http://schemas.openxmlformats.org/drawingml/2006/diagram" xmlns:o="urn:schemas-microsoft-com:office:office" xmlns:v="urn:schemas-microsoft-com:vml" xmlns:pvml="urn:schemas-microsoft-com:office:powerpoint" xmlns:com="http://schemas.openxmlformats.org/drawingml/2006/compatibility" xmlns:p14="http://schemas.microsoft.com/office/powerpoint/2010/main" xmlns:p15="http://schemas.microsoft.com/office/powerpoint/2012/main" xmlns:go="http://customooxmlschemas.google.com/" r:id="rId7" roundtripDataSignature="AMtx7mjdo7FECp685JsX7/4pIVeoAktjNA=="/>
     </p:ext>
   </p:extLst>
 </p:presentation>
@@ -4385,7 +4385,7 @@
             </a:pPr>
             <a:r>
               <a:rPr lang="en-US" sz="1100" dirty="0"/>
-              <a:t>YouTube updates its trending list every 15min using a combination of factors such as the number of views, temperature, age of video, etc. Although its not clear what factors keep a video popping up in the trending list repeatedly. Identifying such features in the data could bolster the success of a video (i.e. make it frequently trend).</a:t>
+              <a:t>YouTube updates its trending list every 15min using a combination of factors such as the number of views, temperature, age of video, etc. Newer videos are often likelier to come up in the refreshed trending list. But besides that its not clear what factors keep a video popping up in the trending list repeatedly. Identifying such features in the data could bolster the success of a video (i.e. make it frequently trend).</a:t>
             </a:r>
           </a:p>
         </p:txBody>

</xml_diff>